<commit_message>
feat(courseware): align Lumina Copilot labs and visual workflow
</commit_message>
<xml_diff>
--- a/activities/lab-04-build-a-powerpoint-story/Lumina-Living-Blank-Leadership-Deck.pptx
+++ b/activities/lab-04-build-a-powerpoint-story/Lumina-Living-Blank-Leadership-Deck.pptx
@@ -110,6 +110,430 @@
     </a:lvl9pPr>
   </p:defaultTextStyle>
 </p:presentation>
+</file>
+
+<file path=ppt/charts/chart1.xml><?xml version="1.0" encoding="utf-8"?>
+<c:chartSpace xmlns:c="http://schemas.openxmlformats.org/drawingml/2006/chart" xmlns:a="http://schemas.openxmlformats.org/drawingml/2006/main" xmlns:r="http://schemas.openxmlformats.org/officeDocument/2006/relationships">
+  <c:date1904 val="0"/>
+  <c:chart>
+    <c:autoTitleDeleted val="0"/>
+    <c:plotArea>
+      <c:lineChart>
+        <c:grouping val="standard"/>
+        <c:varyColors val="0"/>
+        <c:ser>
+          <c:idx val="0"/>
+          <c:order val="0"/>
+          <c:tx>
+            <c:strRef>
+              <c:f>Sheet1!$B$1</c:f>
+              <c:strCache>
+                <c:ptCount val="1"/>
+                <c:pt idx="0">
+                  <c:v>Revenue SGD</c:v>
+                </c:pt>
+              </c:strCache>
+            </c:strRef>
+          </c:tx>
+          <c:cat>
+            <c:strRef>
+              <c:f>Sheet1!$A$2:$A$7</c:f>
+              <c:strCache>
+                <c:ptCount val="6"/>
+                <c:pt idx="0">
+                  <c:v>Jan</c:v>
+                </c:pt>
+                <c:pt idx="1">
+                  <c:v>Feb</c:v>
+                </c:pt>
+                <c:pt idx="2">
+                  <c:v>Mar</c:v>
+                </c:pt>
+                <c:pt idx="3">
+                  <c:v>Apr</c:v>
+                </c:pt>
+                <c:pt idx="4">
+                  <c:v>May</c:v>
+                </c:pt>
+                <c:pt idx="5">
+                  <c:v>Jun</c:v>
+                </c:pt>
+              </c:strCache>
+            </c:strRef>
+          </c:cat>
+          <c:val>
+            <c:numRef>
+              <c:f>Sheet1!$B$2:$B$7</c:f>
+              <c:numCache>
+                <c:formatCode>General</c:formatCode>
+                <c:ptCount val="6"/>
+                <c:pt idx="0">
+                  <c:v>90150</c:v>
+                </c:pt>
+                <c:pt idx="1">
+                  <c:v>145565</c:v>
+                </c:pt>
+                <c:pt idx="2">
+                  <c:v>130880</c:v>
+                </c:pt>
+                <c:pt idx="3">
+                  <c:v>189070</c:v>
+                </c:pt>
+                <c:pt idx="4">
+                  <c:v>159920</c:v>
+                </c:pt>
+                <c:pt idx="5">
+                  <c:v>217705</c:v>
+                </c:pt>
+              </c:numCache>
+            </c:numRef>
+          </c:val>
+          <c:smooth val="0"/>
+        </c:ser>
+        <c:marker val="1"/>
+        <c:smooth val="0"/>
+        <c:axId val="2118791784"/>
+        <c:axId val="2140495176"/>
+      </c:lineChart>
+      <c:catAx>
+        <c:axId val="2118791784"/>
+        <c:scaling>
+          <c:orientation val="minMax"/>
+        </c:scaling>
+        <c:delete val="0"/>
+        <c:axPos val="b"/>
+        <c:majorTickMark val="out"/>
+        <c:minorTickMark val="none"/>
+        <c:tickLblPos val="nextTo"/>
+        <c:txPr>
+          <a:bodyPr/>
+          <a:lstStyle/>
+          <a:p>
+            <a:pPr>
+              <a:defRPr sz="1200"/>
+            </a:pPr>
+          </a:p>
+        </c:txPr>
+        <c:crossAx val="2140495176"/>
+        <c:crosses val="autoZero"/>
+        <c:auto val="1"/>
+        <c:lblAlgn val="ctr"/>
+        <c:lblOffset val="100"/>
+        <c:noMultiLvlLbl val="0"/>
+      </c:catAx>
+      <c:valAx>
+        <c:axId val="2140495176"/>
+        <c:scaling/>
+        <c:delete val="0"/>
+        <c:axPos val="l"/>
+        <c:majorGridlines/>
+        <c:majorTickMark val="out"/>
+        <c:minorTickMark val="none"/>
+        <c:tickLblPos val="nextTo"/>
+        <c:txPr>
+          <a:bodyPr/>
+          <a:lstStyle/>
+          <a:p>
+            <a:pPr>
+              <a:defRPr sz="1200"/>
+            </a:pPr>
+          </a:p>
+        </c:txPr>
+        <c:crossAx val="2118791784"/>
+        <c:crosses val="autoZero"/>
+      </c:valAx>
+    </c:plotArea>
+    <c:legend>
+      <c:legendPos val="r"/>
+      <c:layout/>
+      <c:overlay val="0"/>
+    </c:legend>
+    <c:plotVisOnly val="1"/>
+    <c:dispBlanksAs val="gap"/>
+    <c:showDLblsOverMax val="0"/>
+  </c:chart>
+  <c:txPr>
+    <a:bodyPr/>
+    <a:lstStyle/>
+    <a:p>
+      <a:pPr>
+        <a:defRPr sz="1800"/>
+      </a:pPr>
+      <a:endParaRPr lang="en-US"/>
+    </a:p>
+  </c:txPr>
+  <c:externalData r:id="rId1">
+    <c:autoUpdate val="0"/>
+  </c:externalData>
+</c:chartSpace>
+</file>
+
+<file path=ppt/charts/chart2.xml><?xml version="1.0" encoding="utf-8"?>
+<c:chartSpace xmlns:c="http://schemas.openxmlformats.org/drawingml/2006/chart" xmlns:a="http://schemas.openxmlformats.org/drawingml/2006/main" xmlns:r="http://schemas.openxmlformats.org/officeDocument/2006/relationships">
+  <c:date1904 val="0"/>
+  <c:chart>
+    <c:autoTitleDeleted val="0"/>
+    <c:plotArea>
+      <c:barChart>
+        <c:barDir val="col"/>
+        <c:grouping val="clustered"/>
+        <c:ser>
+          <c:idx val="0"/>
+          <c:order val="0"/>
+          <c:tx>
+            <c:strRef>
+              <c:f>Sheet1!$B$1</c:f>
+              <c:strCache>
+                <c:ptCount val="1"/>
+                <c:pt idx="0">
+                  <c:v>Margin SGD</c:v>
+                </c:pt>
+              </c:strCache>
+            </c:strRef>
+          </c:tx>
+          <c:cat>
+            <c:strRef>
+              <c:f>Sheet1!$A$2:$A$5</c:f>
+              <c:strCache>
+                <c:ptCount val="4"/>
+                <c:pt idx="0">
+                  <c:v>Web</c:v>
+                </c:pt>
+                <c:pt idx="1">
+                  <c:v>Partner</c:v>
+                </c:pt>
+                <c:pt idx="2">
+                  <c:v>Retail</c:v>
+                </c:pt>
+                <c:pt idx="3">
+                  <c:v>Events</c:v>
+                </c:pt>
+              </c:strCache>
+            </c:strRef>
+          </c:cat>
+          <c:val>
+            <c:numRef>
+              <c:f>Sheet1!$B$2:$B$5</c:f>
+              <c:numCache>
+                <c:formatCode>General</c:formatCode>
+                <c:ptCount val="4"/>
+                <c:pt idx="0">
+                  <c:v>84544.39</c:v>
+                </c:pt>
+                <c:pt idx="1">
+                  <c:v>94989.66</c:v>
+                </c:pt>
+                <c:pt idx="2">
+                  <c:v>111411.32</c:v>
+                </c:pt>
+                <c:pt idx="3">
+                  <c:v>121247.22</c:v>
+                </c:pt>
+              </c:numCache>
+            </c:numRef>
+          </c:val>
+        </c:ser>
+        <c:axId val="-2068027336"/>
+        <c:axId val="-2113994440"/>
+      </c:barChart>
+      <c:catAx>
+        <c:axId val="-2068027336"/>
+        <c:scaling>
+          <c:orientation val="minMax"/>
+        </c:scaling>
+        <c:delete val="0"/>
+        <c:axPos val="b"/>
+        <c:majorTickMark val="out"/>
+        <c:minorTickMark val="none"/>
+        <c:tickLblPos val="nextTo"/>
+        <c:txPr>
+          <a:bodyPr/>
+          <a:lstStyle/>
+          <a:p>
+            <a:pPr>
+              <a:defRPr sz="1200"/>
+            </a:pPr>
+          </a:p>
+        </c:txPr>
+        <c:crossAx val="-2113994440"/>
+        <c:crosses val="autoZero"/>
+        <c:auto val="1"/>
+        <c:lblAlgn val="ctr"/>
+        <c:lblOffset val="100"/>
+        <c:noMultiLvlLbl val="0"/>
+      </c:catAx>
+      <c:valAx>
+        <c:axId val="-2113994440"/>
+        <c:scaling/>
+        <c:delete val="0"/>
+        <c:axPos val="l"/>
+        <c:majorGridlines/>
+        <c:majorTickMark val="out"/>
+        <c:minorTickMark val="none"/>
+        <c:tickLblPos val="nextTo"/>
+        <c:txPr>
+          <a:bodyPr/>
+          <a:lstStyle/>
+          <a:p>
+            <a:pPr>
+              <a:defRPr sz="1200"/>
+            </a:pPr>
+          </a:p>
+        </c:txPr>
+        <c:crossAx val="-2068027336"/>
+        <c:crosses val="autoZero"/>
+      </c:valAx>
+    </c:plotArea>
+    <c:dispBlanksAs val="gap"/>
+  </c:chart>
+  <c:txPr>
+    <a:bodyPr/>
+    <a:lstStyle/>
+    <a:p>
+      <a:pPr>
+        <a:defRPr sz="1800"/>
+      </a:pPr>
+      <a:endParaRPr lang="en-US"/>
+    </a:p>
+  </c:txPr>
+  <c:externalData r:id="rId1">
+    <c:autoUpdate val="0"/>
+  </c:externalData>
+</c:chartSpace>
+</file>
+
+<file path=ppt/charts/chart3.xml><?xml version="1.0" encoding="utf-8"?>
+<c:chartSpace xmlns:c="http://schemas.openxmlformats.org/drawingml/2006/chart" xmlns:a="http://schemas.openxmlformats.org/drawingml/2006/main" xmlns:r="http://schemas.openxmlformats.org/officeDocument/2006/relationships">
+  <c:date1904 val="0"/>
+  <c:chart>
+    <c:autoTitleDeleted val="0"/>
+    <c:plotArea>
+      <c:barChart>
+        <c:barDir val="col"/>
+        <c:grouping val="clustered"/>
+        <c:ser>
+          <c:idx val="0"/>
+          <c:order val="0"/>
+          <c:tx>
+            <c:strRef>
+              <c:f>Sheet1!$B$1</c:f>
+              <c:strCache>
+                <c:ptCount val="1"/>
+                <c:pt idx="0">
+                  <c:v>Completion fraction</c:v>
+                </c:pt>
+              </c:strCache>
+            </c:strRef>
+          </c:tx>
+          <c:cat>
+            <c:strRef>
+              <c:f>Sheet1!$A$2:$A$5</c:f>
+              <c:strCache>
+                <c:ptCount val="4"/>
+                <c:pt idx="0">
+                  <c:v>HR</c:v>
+                </c:pt>
+                <c:pt idx="1">
+                  <c:v>Marketing</c:v>
+                </c:pt>
+                <c:pt idx="2">
+                  <c:v>Finance</c:v>
+                </c:pt>
+                <c:pt idx="3">
+                  <c:v>Operations</c:v>
+                </c:pt>
+              </c:strCache>
+            </c:strRef>
+          </c:cat>
+          <c:val>
+            <c:numRef>
+              <c:f>Sheet1!$B$2:$B$5</c:f>
+              <c:numCache>
+                <c:formatCode>General</c:formatCode>
+                <c:ptCount val="4"/>
+                <c:pt idx="0">
+                  <c:v>0.8333333333333334</c:v>
+                </c:pt>
+                <c:pt idx="1">
+                  <c:v>0.875</c:v>
+                </c:pt>
+                <c:pt idx="2">
+                  <c:v>1</c:v>
+                </c:pt>
+                <c:pt idx="3">
+                  <c:v>0.75</c:v>
+                </c:pt>
+              </c:numCache>
+            </c:numRef>
+          </c:val>
+        </c:ser>
+        <c:axId val="-2068027336"/>
+        <c:axId val="-2113994440"/>
+      </c:barChart>
+      <c:catAx>
+        <c:axId val="-2068027336"/>
+        <c:scaling>
+          <c:orientation val="minMax"/>
+        </c:scaling>
+        <c:delete val="0"/>
+        <c:axPos val="b"/>
+        <c:majorTickMark val="out"/>
+        <c:minorTickMark val="none"/>
+        <c:tickLblPos val="nextTo"/>
+        <c:txPr>
+          <a:bodyPr/>
+          <a:lstStyle/>
+          <a:p>
+            <a:pPr>
+              <a:defRPr sz="1200"/>
+            </a:pPr>
+          </a:p>
+        </c:txPr>
+        <c:crossAx val="-2113994440"/>
+        <c:crosses val="autoZero"/>
+        <c:auto val="1"/>
+        <c:lblAlgn val="ctr"/>
+        <c:lblOffset val="100"/>
+        <c:noMultiLvlLbl val="0"/>
+      </c:catAx>
+      <c:valAx>
+        <c:axId val="-2113994440"/>
+        <c:scaling/>
+        <c:delete val="0"/>
+        <c:axPos val="l"/>
+        <c:majorGridlines/>
+        <c:majorTickMark val="out"/>
+        <c:minorTickMark val="none"/>
+        <c:tickLblPos val="nextTo"/>
+        <c:txPr>
+          <a:bodyPr/>
+          <a:lstStyle/>
+          <a:p>
+            <a:pPr>
+              <a:defRPr sz="1200"/>
+            </a:pPr>
+          </a:p>
+        </c:txPr>
+        <c:crossAx val="-2068027336"/>
+        <c:crosses val="autoZero"/>
+      </c:valAx>
+    </c:plotArea>
+    <c:dispBlanksAs val="gap"/>
+  </c:chart>
+  <c:txPr>
+    <a:bodyPr/>
+    <a:lstStyle/>
+    <a:p>
+      <a:pPr>
+        <a:defRPr sz="1800"/>
+      </a:pPr>
+      <a:endParaRPr lang="en-US"/>
+    </a:p>
+  </c:txPr>
+  <c:externalData r:id="rId1">
+    <c:autoUpdate val="0"/>
+  </c:externalData>
+</c:chartSpace>
 </file>
 
 <file path=ppt/slideLayouts/slideLayout1.xml><?xml version="1.0" encoding="utf-8"?>
@@ -3086,14 +3510,6 @@
 <file path=ppt/slides/slide1.xml><?xml version="1.0" encoding="utf-8"?>
 <p:sld xmlns:a="http://schemas.openxmlformats.org/drawingml/2006/main" xmlns:p="http://schemas.openxmlformats.org/presentationml/2006/main" xmlns:r="http://schemas.openxmlformats.org/officeDocument/2006/relationships">
   <p:cSld>
-    <p:bg>
-      <p:bgPr>
-        <a:solidFill>
-          <a:srgbClr val="FFFFFF"/>
-        </a:solidFill>
-        <a:effectLst/>
-      </p:bgPr>
-    </p:bg>
     <p:spTree>
       <p:nvGrpSpPr>
         <p:cNvPr id="1" name=""/>
@@ -3109,8 +3525,8 @@
         </p:nvSpPr>
         <p:spPr>
           <a:xfrm>
-            <a:off x="731520" y="502920"/>
-            <a:ext cx="10698480" cy="731520"/>
+            <a:off x="594360" y="365760"/>
+            <a:ext cx="10972800" cy="914400"/>
           </a:xfrm>
           <a:prstGeom prst="rect">
             <a:avLst/>
@@ -3124,15 +3540,10 @@
           <a:lstStyle/>
           <a:p>
             <a:pPr>
-              <a:defRPr sz="3000" b="1">
-                <a:solidFill>
-                  <a:srgbClr val="161B26"/>
-                </a:solidFill>
-                <a:latin typeface="Arial"/>
-              </a:defRPr>
+              <a:defRPr sz="2900" b="1"/>
             </a:pPr>
             <a:r>
-              <a:t>Sustainable Workspace Campaign</a:t>
+              <a:t>Launch decision depends on readiness</a:t>
             </a:r>
           </a:p>
         </p:txBody>
@@ -3145,8 +3556,8 @@
         </p:nvSpPr>
         <p:spPr>
           <a:xfrm>
-            <a:off x="822960" y="1600200"/>
-            <a:ext cx="3931920" cy="4206240"/>
+            <a:off x="640080" y="1554480"/>
+            <a:ext cx="10607040" cy="4114800"/>
           </a:xfrm>
           <a:prstGeom prst="rect">
             <a:avLst/>
@@ -3160,15 +3571,35 @@
           <a:lstStyle/>
           <a:p>
             <a:pPr>
-              <a:defRPr sz="1800">
-                <a:solidFill>
-                  <a:srgbClr val="5B6372"/>
-                </a:solidFill>
-                <a:latin typeface="Arial"/>
-              </a:defRPr>
+              <a:spcAft>
+                <a:spcPts val="1500"/>
+              </a:spcAft>
+              <a:defRPr sz="1800"/>
             </a:pPr>
             <a:r>
-              <a:t>Decision-led evidence goes here.</a:t>
+              <a:t>Planned launch: 1 October 2026</a:t>
+            </a:r>
+          </a:p>
+          <a:p>
+            <a:pPr>
+              <a:spcAft>
+                <a:spcPts val="1500"/>
+              </a:spcAft>
+              <a:defRPr sz="1800"/>
+            </a:pPr>
+            <a:r>
+              <a:t>Budget:SGD 18,000; target: 120 qualified enquiries</a:t>
+            </a:r>
+          </a:p>
+          <a:p>
+            <a:pPr>
+              <a:spcAft>
+                <a:spcPts val="1500"/>
+              </a:spcAft>
+              <a:defRPr sz="1800"/>
+            </a:pPr>
+            <a:r>
+              <a:t>Review copy, financial evidence, HR training and Operations readiness before approval.</a:t>
             </a:r>
           </a:p>
         </p:txBody>
@@ -3181,8 +3612,8 @@
         </p:nvSpPr>
         <p:spPr>
           <a:xfrm>
-            <a:off x="731520" y="6419088"/>
-            <a:ext cx="10698480" cy="228600"/>
+            <a:off x="640080" y="6126480"/>
+            <a:ext cx="10972800" cy="457200"/>
           </a:xfrm>
           <a:prstGeom prst="rect">
             <a:avLst/>
@@ -3195,16 +3626,11 @@
           </a:bodyPr>
           <a:lstStyle/>
           <a:p>
-            <a:pPr algn="ctr">
-              <a:defRPr sz="800">
-                <a:solidFill>
-                  <a:srgbClr val="5B6372"/>
-                </a:solidFill>
-                <a:latin typeface="Arial"/>
-              </a:defRPr>
+            <a:pPr>
+              <a:defRPr sz="1000"/>
             </a:pPr>
             <a:r>
-              <a:t>Lumina Living · TGS-2024043856 · © 2026 Tertiary Infotech Academy Pte Ltd</a:t>
+              <a:t>Lumina Living | SW-2026 | Synthetic data | DRAFT FOR REVIEW | Source: Lumina-Business-Data.xlsx</a:t>
             </a:r>
           </a:p>
         </p:txBody>
@@ -3220,14 +3646,6 @@
 <file path=ppt/slides/slide2.xml><?xml version="1.0" encoding="utf-8"?>
 <p:sld xmlns:a="http://schemas.openxmlformats.org/drawingml/2006/main" xmlns:p="http://schemas.openxmlformats.org/presentationml/2006/main" xmlns:r="http://schemas.openxmlformats.org/officeDocument/2006/relationships">
   <p:cSld>
-    <p:bg>
-      <p:bgPr>
-        <a:solidFill>
-          <a:srgbClr val="FFFFFF"/>
-        </a:solidFill>
-        <a:effectLst/>
-      </p:bgPr>
-    </p:bg>
     <p:spTree>
       <p:nvGrpSpPr>
         <p:cNvPr id="1" name=""/>
@@ -3243,8 +3661,8 @@
         </p:nvSpPr>
         <p:spPr>
           <a:xfrm>
-            <a:off x="731520" y="502920"/>
-            <a:ext cx="10698480" cy="731520"/>
+            <a:off x="594360" y="365760"/>
+            <a:ext cx="10972800" cy="914400"/>
           </a:xfrm>
           <a:prstGeom prst="rect">
             <a:avLst/>
@@ -3258,15 +3676,10 @@
           <a:lstStyle/>
           <a:p>
             <a:pPr>
-              <a:defRPr sz="3000" b="1">
-                <a:solidFill>
-                  <a:srgbClr val="161B26"/>
-                </a:solidFill>
-                <a:latin typeface="Arial"/>
-              </a:defRPr>
+              <a:defRPr sz="2900" b="1"/>
             </a:pPr>
             <a:r>
-              <a:t>The customer need</a:t>
+              <a:t>Historical revenue provides the baseline</a:t>
             </a:r>
           </a:p>
         </p:txBody>
@@ -3279,8 +3692,8 @@
         </p:nvSpPr>
         <p:spPr>
           <a:xfrm>
-            <a:off x="822960" y="1600200"/>
-            <a:ext cx="3931920" cy="4206240"/>
+            <a:off x="640080" y="1554480"/>
+            <a:ext cx="3749039" cy="4114800"/>
           </a:xfrm>
           <a:prstGeom prst="rect">
             <a:avLst/>
@@ -3294,29 +3707,67 @@
           <a:lstStyle/>
           <a:p>
             <a:pPr>
-              <a:defRPr sz="1800">
-                <a:solidFill>
-                  <a:srgbClr val="5B6372"/>
-                </a:solidFill>
-                <a:latin typeface="Arial"/>
-              </a:defRPr>
+              <a:spcAft>
+                <a:spcPts val="1500"/>
+              </a:spcAft>
+              <a:defRPr sz="1800"/>
             </a:pPr>
             <a:r>
-              <a:t>Decision-led evidence goes here.</a:t>
-            </a:r>
-          </a:p>
-        </p:txBody>
-      </p:sp>
-      <p:sp>
-        <p:nvSpPr>
-          <p:cNvPr id="4" name="TextBox 3"/>
+              <a:t>Jan–Jun revenue:SGD 933,290</a:t>
+            </a:r>
+          </a:p>
+          <a:p>
+            <a:pPr>
+              <a:spcAft>
+                <a:spcPts val="1500"/>
+              </a:spcAft>
+              <a:defRPr sz="1800"/>
+            </a:pPr>
+            <a:r>
+              <a:t>Use the historical pattern as context; it is not an October forecast.</a:t>
+            </a:r>
+          </a:p>
+          <a:p>
+            <a:pPr>
+              <a:spcAft>
+                <a:spcPts val="1500"/>
+              </a:spcAft>
+              <a:defRPr sz="1800"/>
+            </a:pPr>
+            <a:r>
+              <a:t>Source:Monthly!A2:B7</a:t>
+            </a:r>
+          </a:p>
+        </p:txBody>
+      </p:sp>
+      <p:graphicFrame>
+        <p:nvGraphicFramePr>
+          <p:cNvPr id="4" name="Chart 3"/>
+          <p:cNvGraphicFramePr>
+            <a:graphicFrameLocks noGrp="1"/>
+          </p:cNvGraphicFramePr>
+          <p:nvPr/>
+        </p:nvGraphicFramePr>
+        <p:xfrm>
+          <a:off x="4572000" y="1554480"/>
+          <a:ext cx="6858000" cy="4297680"/>
+        </p:xfrm>
+        <a:graphic>
+          <a:graphicData uri="http://schemas.openxmlformats.org/drawingml/2006/chart">
+            <c:chart xmlns:c="http://schemas.openxmlformats.org/drawingml/2006/chart" r:id="rId2"/>
+          </a:graphicData>
+        </a:graphic>
+      </p:graphicFrame>
+      <p:sp>
+        <p:nvSpPr>
+          <p:cNvPr id="5" name="TextBox 4"/>
           <p:cNvSpPr txBox="1"/>
           <p:nvPr/>
         </p:nvSpPr>
         <p:spPr>
           <a:xfrm>
-            <a:off x="731520" y="6419088"/>
-            <a:ext cx="10698480" cy="228600"/>
+            <a:off x="640080" y="6126480"/>
+            <a:ext cx="10972800" cy="457200"/>
           </a:xfrm>
           <a:prstGeom prst="rect">
             <a:avLst/>
@@ -3329,16 +3780,11 @@
           </a:bodyPr>
           <a:lstStyle/>
           <a:p>
-            <a:pPr algn="ctr">
-              <a:defRPr sz="800">
-                <a:solidFill>
-                  <a:srgbClr val="5B6372"/>
-                </a:solidFill>
-                <a:latin typeface="Arial"/>
-              </a:defRPr>
+            <a:pPr>
+              <a:defRPr sz="1000"/>
             </a:pPr>
             <a:r>
-              <a:t>Lumina Living · TGS-2024043856 · © 2026 Tertiary Infotech Academy Pte Ltd</a:t>
+              <a:t>Lumina Living | SW-2026 | Synthetic data | DRAFT FOR REVIEW | Source: Lumina-Business-Data.xlsx</a:t>
             </a:r>
           </a:p>
         </p:txBody>
@@ -3354,14 +3800,6 @@
 <file path=ppt/slides/slide3.xml><?xml version="1.0" encoding="utf-8"?>
 <p:sld xmlns:a="http://schemas.openxmlformats.org/drawingml/2006/main" xmlns:p="http://schemas.openxmlformats.org/presentationml/2006/main" xmlns:r="http://schemas.openxmlformats.org/officeDocument/2006/relationships">
   <p:cSld>
-    <p:bg>
-      <p:bgPr>
-        <a:solidFill>
-          <a:srgbClr val="FFFFFF"/>
-        </a:solidFill>
-        <a:effectLst/>
-      </p:bgPr>
-    </p:bg>
     <p:spTree>
       <p:nvGrpSpPr>
         <p:cNvPr id="1" name=""/>
@@ -3377,8 +3815,8 @@
         </p:nvSpPr>
         <p:spPr>
           <a:xfrm>
-            <a:off x="731520" y="502920"/>
-            <a:ext cx="10698480" cy="731520"/>
+            <a:off x="594360" y="365760"/>
+            <a:ext cx="10972800" cy="914400"/>
           </a:xfrm>
           <a:prstGeom prst="rect">
             <a:avLst/>
@@ -3392,15 +3830,10 @@
           <a:lstStyle/>
           <a:p>
             <a:pPr>
-              <a:defRPr sz="3000" b="1">
-                <a:solidFill>
-                  <a:srgbClr val="161B26"/>
-                </a:solidFill>
-                <a:latin typeface="Arial"/>
-              </a:defRPr>
+              <a:defRPr sz="2900" b="1"/>
             </a:pPr>
             <a:r>
-              <a:t>Evidence and opportunity</a:t>
+              <a:t>Events leads historical margin contribution</a:t>
             </a:r>
           </a:p>
         </p:txBody>
@@ -3413,8 +3846,8 @@
         </p:nvSpPr>
         <p:spPr>
           <a:xfrm>
-            <a:off x="822960" y="1600200"/>
-            <a:ext cx="3931920" cy="4206240"/>
+            <a:off x="640080" y="1554480"/>
+            <a:ext cx="3749039" cy="4114800"/>
           </a:xfrm>
           <a:prstGeom prst="rect">
             <a:avLst/>
@@ -3428,29 +3861,67 @@
           <a:lstStyle/>
           <a:p>
             <a:pPr>
-              <a:defRPr sz="1800">
-                <a:solidFill>
-                  <a:srgbClr val="5B6372"/>
-                </a:solidFill>
-                <a:latin typeface="Arial"/>
-              </a:defRPr>
+              <a:spcAft>
+                <a:spcPts val="1500"/>
+              </a:spcAft>
+              <a:defRPr sz="1800"/>
             </a:pPr>
             <a:r>
-              <a:t>Decision-led evidence goes here.</a:t>
-            </a:r>
-          </a:p>
-        </p:txBody>
-      </p:sp>
-      <p:sp>
-        <p:nvSpPr>
-          <p:cNvPr id="4" name="TextBox 3"/>
+              <a:t>Total margin:SGD 412,193</a:t>
+            </a:r>
+          </a:p>
+          <a:p>
+            <a:pPr>
+              <a:spcAft>
+                <a:spcPts val="1500"/>
+              </a:spcAft>
+              <a:defRPr sz="1800"/>
+            </a:pPr>
+            <a:r>
+              <a:t>Margin is revenue minus the supplied cost, not net profit.</a:t>
+            </a:r>
+          </a:p>
+          <a:p>
+            <a:pPr>
+              <a:spcAft>
+                <a:spcPts val="1500"/>
+              </a:spcAft>
+              <a:defRPr sz="1800"/>
+            </a:pPr>
+            <a:r>
+              <a:t>Source:Channels!A2:D5</a:t>
+            </a:r>
+          </a:p>
+        </p:txBody>
+      </p:sp>
+      <p:graphicFrame>
+        <p:nvGraphicFramePr>
+          <p:cNvPr id="4" name="Chart 3"/>
+          <p:cNvGraphicFramePr>
+            <a:graphicFrameLocks noGrp="1"/>
+          </p:cNvGraphicFramePr>
+          <p:nvPr/>
+        </p:nvGraphicFramePr>
+        <p:xfrm>
+          <a:off x="4572000" y="1554480"/>
+          <a:ext cx="6858000" cy="4297680"/>
+        </p:xfrm>
+        <a:graphic>
+          <a:graphicData uri="http://schemas.openxmlformats.org/drawingml/2006/chart">
+            <c:chart xmlns:c="http://schemas.openxmlformats.org/drawingml/2006/chart" r:id="rId2"/>
+          </a:graphicData>
+        </a:graphic>
+      </p:graphicFrame>
+      <p:sp>
+        <p:nvSpPr>
+          <p:cNvPr id="5" name="TextBox 4"/>
           <p:cNvSpPr txBox="1"/>
           <p:nvPr/>
         </p:nvSpPr>
         <p:spPr>
           <a:xfrm>
-            <a:off x="731520" y="6419088"/>
-            <a:ext cx="10698480" cy="228600"/>
+            <a:off x="640080" y="6126480"/>
+            <a:ext cx="10972800" cy="457200"/>
           </a:xfrm>
           <a:prstGeom prst="rect">
             <a:avLst/>
@@ -3463,16 +3934,11 @@
           </a:bodyPr>
           <a:lstStyle/>
           <a:p>
-            <a:pPr algn="ctr">
-              <a:defRPr sz="800">
-                <a:solidFill>
-                  <a:srgbClr val="5B6372"/>
-                </a:solidFill>
-                <a:latin typeface="Arial"/>
-              </a:defRPr>
+            <a:pPr>
+              <a:defRPr sz="1000"/>
             </a:pPr>
             <a:r>
-              <a:t>Lumina Living · TGS-2024043856 · © 2026 Tertiary Infotech Academy Pte Ltd</a:t>
+              <a:t>Lumina Living | SW-2026 | Synthetic data | DRAFT FOR REVIEW | Source: Lumina-Business-Data.xlsx</a:t>
             </a:r>
           </a:p>
         </p:txBody>
@@ -3488,14 +3954,6 @@
 <file path=ppt/slides/slide4.xml><?xml version="1.0" encoding="utf-8"?>
 <p:sld xmlns:a="http://schemas.openxmlformats.org/drawingml/2006/main" xmlns:p="http://schemas.openxmlformats.org/presentationml/2006/main" xmlns:r="http://schemas.openxmlformats.org/officeDocument/2006/relationships">
   <p:cSld>
-    <p:bg>
-      <p:bgPr>
-        <a:solidFill>
-          <a:srgbClr val="FFFFFF"/>
-        </a:solidFill>
-        <a:effectLst/>
-      </p:bgPr>
-    </p:bg>
     <p:spTree>
       <p:nvGrpSpPr>
         <p:cNvPr id="1" name=""/>
@@ -3511,8 +3969,8 @@
         </p:nvSpPr>
         <p:spPr>
           <a:xfrm>
-            <a:off x="731520" y="502920"/>
-            <a:ext cx="10698480" cy="731520"/>
+            <a:off x="594360" y="365760"/>
+            <a:ext cx="10972800" cy="914400"/>
           </a:xfrm>
           <a:prstGeom prst="rect">
             <a:avLst/>
@@ -3526,15 +3984,10 @@
           <a:lstStyle/>
           <a:p>
             <a:pPr>
-              <a:defRPr sz="3000" b="1">
-                <a:solidFill>
-                  <a:srgbClr val="161B26"/>
-                </a:solidFill>
-                <a:latin typeface="Arial"/>
-              </a:defRPr>
+              <a:defRPr sz="2900" b="1"/>
             </a:pPr>
             <a:r>
-              <a:t>Campaign plan</a:t>
+              <a:t>Nine employees still need training</a:t>
             </a:r>
           </a:p>
         </p:txBody>
@@ -3547,8 +4000,8 @@
         </p:nvSpPr>
         <p:spPr>
           <a:xfrm>
-            <a:off x="822960" y="1600200"/>
-            <a:ext cx="3931920" cy="4206240"/>
+            <a:off x="640080" y="1554480"/>
+            <a:ext cx="3749039" cy="4114800"/>
           </a:xfrm>
           <a:prstGeom prst="rect">
             <a:avLst/>
@@ -3562,29 +4015,78 @@
           <a:lstStyle/>
           <a:p>
             <a:pPr>
-              <a:defRPr sz="1800">
-                <a:solidFill>
-                  <a:srgbClr val="5B6372"/>
-                </a:solidFill>
-                <a:latin typeface="Arial"/>
-              </a:defRPr>
+              <a:spcAft>
+                <a:spcPts val="1500"/>
+              </a:spcAft>
+              <a:defRPr sz="1800"/>
             </a:pPr>
             <a:r>
-              <a:t>Decision-led evidence goes here.</a:t>
-            </a:r>
-          </a:p>
-        </p:txBody>
-      </p:sp>
-      <p:sp>
-        <p:nvSpPr>
-          <p:cNvPr id="4" name="TextBox 3"/>
+              <a:t>47/56 trained: 83.9%</a:t>
+            </a:r>
+          </a:p>
+          <a:p>
+            <a:pPr>
+              <a:spcAft>
+                <a:spcPts val="1500"/>
+              </a:spcAft>
+              <a:defRPr sz="1800"/>
+            </a:pPr>
+            <a:r>
+              <a:t>Operations has five of the nine gaps.</a:t>
+            </a:r>
+          </a:p>
+          <a:p>
+            <a:pPr>
+              <a:spcAft>
+                <a:spcPts val="1500"/>
+              </a:spcAft>
+              <a:defRPr sz="1800"/>
+            </a:pPr>
+            <a:r>
+              <a:t>Aisha owns completion by 24 September.</a:t>
+            </a:r>
+          </a:p>
+          <a:p>
+            <a:pPr>
+              <a:spcAft>
+                <a:spcPts val="1500"/>
+              </a:spcAft>
+              <a:defRPr sz="1800"/>
+            </a:pPr>
+            <a:r>
+              <a:t>Source:HR_Readiness!A2:E6</a:t>
+            </a:r>
+          </a:p>
+        </p:txBody>
+      </p:sp>
+      <p:graphicFrame>
+        <p:nvGraphicFramePr>
+          <p:cNvPr id="4" name="Chart 3"/>
+          <p:cNvGraphicFramePr>
+            <a:graphicFrameLocks noGrp="1"/>
+          </p:cNvGraphicFramePr>
+          <p:nvPr/>
+        </p:nvGraphicFramePr>
+        <p:xfrm>
+          <a:off x="4572000" y="1554480"/>
+          <a:ext cx="6858000" cy="4297680"/>
+        </p:xfrm>
+        <a:graphic>
+          <a:graphicData uri="http://schemas.openxmlformats.org/drawingml/2006/chart">
+            <c:chart xmlns:c="http://schemas.openxmlformats.org/drawingml/2006/chart" r:id="rId2"/>
+          </a:graphicData>
+        </a:graphic>
+      </p:graphicFrame>
+      <p:sp>
+        <p:nvSpPr>
+          <p:cNvPr id="5" name="TextBox 4"/>
           <p:cNvSpPr txBox="1"/>
           <p:nvPr/>
         </p:nvSpPr>
         <p:spPr>
           <a:xfrm>
-            <a:off x="731520" y="6419088"/>
-            <a:ext cx="10698480" cy="228600"/>
+            <a:off x="640080" y="6126480"/>
+            <a:ext cx="10972800" cy="457200"/>
           </a:xfrm>
           <a:prstGeom prst="rect">
             <a:avLst/>
@@ -3597,16 +4099,11 @@
           </a:bodyPr>
           <a:lstStyle/>
           <a:p>
-            <a:pPr algn="ctr">
-              <a:defRPr sz="800">
-                <a:solidFill>
-                  <a:srgbClr val="5B6372"/>
-                </a:solidFill>
-                <a:latin typeface="Arial"/>
-              </a:defRPr>
+            <a:pPr>
+              <a:defRPr sz="1000"/>
             </a:pPr>
             <a:r>
-              <a:t>Lumina Living · TGS-2024043856 · © 2026 Tertiary Infotech Academy Pte Ltd</a:t>
+              <a:t>Lumina Living | SW-2026 | Synthetic data | DRAFT FOR REVIEW | Source: Lumina-Business-Data.xlsx</a:t>
             </a:r>
           </a:p>
         </p:txBody>
@@ -3622,14 +4119,6 @@
 <file path=ppt/slides/slide5.xml><?xml version="1.0" encoding="utf-8"?>
 <p:sld xmlns:a="http://schemas.openxmlformats.org/drawingml/2006/main" xmlns:p="http://schemas.openxmlformats.org/presentationml/2006/main" xmlns:r="http://schemas.openxmlformats.org/officeDocument/2006/relationships">
   <p:cSld>
-    <p:bg>
-      <p:bgPr>
-        <a:solidFill>
-          <a:srgbClr val="FFFFFF"/>
-        </a:solidFill>
-        <a:effectLst/>
-      </p:bgPr>
-    </p:bg>
     <p:spTree>
       <p:nvGrpSpPr>
         <p:cNvPr id="1" name=""/>
@@ -3645,8 +4134,8 @@
         </p:nvSpPr>
         <p:spPr>
           <a:xfrm>
-            <a:off x="731520" y="502920"/>
-            <a:ext cx="10698480" cy="731520"/>
+            <a:off x="594360" y="365760"/>
+            <a:ext cx="10972800" cy="914400"/>
           </a:xfrm>
           <a:prstGeom prst="rect">
             <a:avLst/>
@@ -3660,15 +4149,10 @@
           <a:lstStyle/>
           <a:p>
             <a:pPr>
-              <a:defRPr sz="3000" b="1">
-                <a:solidFill>
-                  <a:srgbClr val="161B26"/>
-                </a:solidFill>
-                <a:latin typeface="Arial"/>
-              </a:defRPr>
+              <a:defRPr sz="2900" b="1"/>
             </a:pPr>
             <a:r>
-              <a:t>Risk and controls</a:t>
+              <a:t>Claims and source limits shape the message</a:t>
             </a:r>
           </a:p>
         </p:txBody>
@@ -3681,8 +4165,8 @@
         </p:nvSpPr>
         <p:spPr>
           <a:xfrm>
-            <a:off x="822960" y="1600200"/>
-            <a:ext cx="3931920" cy="4206240"/>
+            <a:off x="640080" y="1554480"/>
+            <a:ext cx="10607040" cy="4114800"/>
           </a:xfrm>
           <a:prstGeom prst="rect">
             <a:avLst/>
@@ -3696,15 +4180,46 @@
           <a:lstStyle/>
           <a:p>
             <a:pPr>
-              <a:defRPr sz="1800">
-                <a:solidFill>
-                  <a:srgbClr val="5B6372"/>
-                </a:solidFill>
-                <a:latin typeface="Arial"/>
-              </a:defRPr>
+              <a:spcAft>
+                <a:spcPts val="1500"/>
+              </a:spcAft>
+              <a:defRPr sz="1800"/>
             </a:pPr>
             <a:r>
-              <a:t>Decision-led evidence goes here.</a:t>
+              <a:t>Use:workspace products designed for reuse and repair.</a:t>
+            </a:r>
+          </a:p>
+          <a:p>
+            <a:pPr>
+              <a:spcAft>
+                <a:spcPts val="1500"/>
+              </a:spcAft>
+              <a:defRPr sz="1800"/>
+            </a:pPr>
+            <a:r>
+              <a:t>Do not claim carbon neutrality or unsupported certification.</a:t>
+            </a:r>
+          </a:p>
+          <a:p>
+            <a:pPr>
+              <a:spcAft>
+                <a:spcPts val="1500"/>
+              </a:spcAft>
+              <a:defRPr sz="1800"/>
+            </a:pPr>
+            <a:r>
+              <a:t>The campaign budget and target are planned; keep them separate from historical performance.</a:t>
+            </a:r>
+          </a:p>
+          <a:p>
+            <a:pPr>
+              <a:spcAft>
+                <a:spcPts val="1500"/>
+              </a:spcAft>
+              <a:defRPr sz="1800"/>
+            </a:pPr>
+            <a:r>
+              <a:t>Source:CAM-2026-Q4; HR-01.</a:t>
             </a:r>
           </a:p>
         </p:txBody>
@@ -3717,8 +4232,8 @@
         </p:nvSpPr>
         <p:spPr>
           <a:xfrm>
-            <a:off x="731520" y="6419088"/>
-            <a:ext cx="10698480" cy="228600"/>
+            <a:off x="640080" y="6126480"/>
+            <a:ext cx="10972800" cy="457200"/>
           </a:xfrm>
           <a:prstGeom prst="rect">
             <a:avLst/>
@@ -3731,16 +4246,11 @@
           </a:bodyPr>
           <a:lstStyle/>
           <a:p>
-            <a:pPr algn="ctr">
-              <a:defRPr sz="800">
-                <a:solidFill>
-                  <a:srgbClr val="5B6372"/>
-                </a:solidFill>
-                <a:latin typeface="Arial"/>
-              </a:defRPr>
+            <a:pPr>
+              <a:defRPr sz="1000"/>
             </a:pPr>
             <a:r>
-              <a:t>Lumina Living · TGS-2024043856 · © 2026 Tertiary Infotech Academy Pte Ltd</a:t>
+              <a:t>Lumina Living | SW-2026 | Synthetic data | DRAFT FOR REVIEW | Source: Lumina-Business-Data.xlsx</a:t>
             </a:r>
           </a:p>
         </p:txBody>
@@ -3756,14 +4266,6 @@
 <file path=ppt/slides/slide6.xml><?xml version="1.0" encoding="utf-8"?>
 <p:sld xmlns:a="http://schemas.openxmlformats.org/drawingml/2006/main" xmlns:p="http://schemas.openxmlformats.org/presentationml/2006/main" xmlns:r="http://schemas.openxmlformats.org/officeDocument/2006/relationships">
   <p:cSld>
-    <p:bg>
-      <p:bgPr>
-        <a:solidFill>
-          <a:srgbClr val="FFFFFF"/>
-        </a:solidFill>
-        <a:effectLst/>
-      </p:bgPr>
-    </p:bg>
     <p:spTree>
       <p:nvGrpSpPr>
         <p:cNvPr id="1" name=""/>
@@ -3779,8 +4281,8 @@
         </p:nvSpPr>
         <p:spPr>
           <a:xfrm>
-            <a:off x="731520" y="502920"/>
-            <a:ext cx="10698480" cy="731520"/>
+            <a:off x="594360" y="365760"/>
+            <a:ext cx="10972800" cy="914400"/>
           </a:xfrm>
           <a:prstGeom prst="rect">
             <a:avLst/>
@@ -3794,15 +4296,10 @@
           <a:lstStyle/>
           <a:p>
             <a:pPr>
-              <a:defRPr sz="3000" b="1">
-                <a:solidFill>
-                  <a:srgbClr val="161B26"/>
-                </a:solidFill>
-                <a:latin typeface="Arial"/>
-              </a:defRPr>
+              <a:defRPr sz="2900" b="1"/>
             </a:pPr>
             <a:r>
-              <a:t>Decision required</a:t>
+              <a:t>Keep four actions consistent across apps</a:t>
             </a:r>
           </a:p>
         </p:txBody>
@@ -3815,8 +4312,8 @@
         </p:nvSpPr>
         <p:spPr>
           <a:xfrm>
-            <a:off x="822960" y="1600200"/>
-            <a:ext cx="3931920" cy="4206240"/>
+            <a:off x="640080" y="1554480"/>
+            <a:ext cx="10607040" cy="4114800"/>
           </a:xfrm>
           <a:prstGeom prst="rect">
             <a:avLst/>
@@ -3830,15 +4327,57 @@
           <a:lstStyle/>
           <a:p>
             <a:pPr>
-              <a:defRPr sz="1800">
-                <a:solidFill>
-                  <a:srgbClr val="5B6372"/>
-                </a:solidFill>
-                <a:latin typeface="Arial"/>
-              </a:defRPr>
+              <a:spcAft>
+                <a:spcPts val="1500"/>
+              </a:spcAft>
+              <a:defRPr sz="1800"/>
             </a:pPr>
             <a:r>
-              <a:t>Decision-led evidence goes here.</a:t>
+              <a:t>A01 HR — train remaining staff — 24 September</a:t>
+            </a:r>
+          </a:p>
+          <a:p>
+            <a:pPr>
+              <a:spcAft>
+                <a:spcPts val="1500"/>
+              </a:spcAft>
+              <a:defRPr sz="1800"/>
+            </a:pPr>
+            <a:r>
+              <a:t>A02 Marketing — review copy — 23 September</a:t>
+            </a:r>
+          </a:p>
+          <a:p>
+            <a:pPr>
+              <a:spcAft>
+                <a:spcPts val="1500"/>
+              </a:spcAft>
+              <a:defRPr sz="1800"/>
+            </a:pPr>
+            <a:r>
+              <a:t>A03 Finance — verify figures — 25 September</a:t>
+            </a:r>
+          </a:p>
+          <a:p>
+            <a:pPr>
+              <a:spcAft>
+                <a:spcPts val="1500"/>
+              </a:spcAft>
+              <a:defRPr sz="1800"/>
+            </a:pPr>
+            <a:r>
+              <a:t>A04 Operations — confirm service readiness — 25 September</a:t>
+            </a:r>
+          </a:p>
+          <a:p>
+            <a:pPr>
+              <a:spcAft>
+                <a:spcPts val="1500"/>
+              </a:spcAft>
+              <a:defRPr sz="1800"/>
+            </a:pPr>
+            <a:r>
+              <a:t>Record evidence in the Loop register. Human review precedes delivery.</a:t>
             </a:r>
           </a:p>
         </p:txBody>
@@ -3851,8 +4390,8 @@
         </p:nvSpPr>
         <p:spPr>
           <a:xfrm>
-            <a:off x="731520" y="6419088"/>
-            <a:ext cx="10698480" cy="228600"/>
+            <a:off x="640080" y="6126480"/>
+            <a:ext cx="10972800" cy="457200"/>
           </a:xfrm>
           <a:prstGeom prst="rect">
             <a:avLst/>
@@ -3865,16 +4404,11 @@
           </a:bodyPr>
           <a:lstStyle/>
           <a:p>
-            <a:pPr algn="ctr">
-              <a:defRPr sz="800">
-                <a:solidFill>
-                  <a:srgbClr val="5B6372"/>
-                </a:solidFill>
-                <a:latin typeface="Arial"/>
-              </a:defRPr>
+            <a:pPr>
+              <a:defRPr sz="1000"/>
             </a:pPr>
             <a:r>
-              <a:t>Lumina Living · TGS-2024043856 · © 2026 Tertiary Infotech Academy Pte Ltd</a:t>
+              <a:t>Lumina Living | SW-2026 | Synthetic data | DRAFT FOR REVIEW | Source: Lumina-Business-Data.xlsx</a:t>
             </a:r>
           </a:p>
         </p:txBody>

</xml_diff>